<commit_message>
Deck: surface the in-browser live tracker; refresh PDF
The pitch claimed a hosted replay console as the live demo. There is now a
zero-install in-browser tracker (docs/live.html) that runs the real detection
loop on a judge's own laptop or phone camera, which is a materially stronger
claim -- so slide 2 (already built / caption), slide 4 (feasibility) and
slide 6 (links) now say so.

Kept to in-place text edits: the deck follows the mandated six-slide SIH
template and every slide was already full, so nothing was added, moved or
restyled. Each edited slide was rendered and checked for overflow before
committing -- the first attempt wrapped the slide-2 caption into the
"Measured:" line and was reworded rather than shipped.

Co-Authored-By: Claude Opus 5 <noreply@anthropic.com>
</commit_message>
<xml_diff>
--- a/docs/submission/ZeroDrift_SIH26169.pptx
+++ b/docs/submission/ZeroDrift_SIH26169.pptx
@@ -6648,7 +6648,7 @@
                 </a:solidFill>
                 <a:latin typeface="Arial"/>
               </a:rPr>
-              <a:t>GUI console, standalone app, hosted replay console, 73 automated tests — every number here is measured, not projected.</a:t>
+              <a:t>GUI console, standalone app, 73 automated tests, and a zero-install browser demo judges run on their own camera — every number measured, not projected.</a:t>
             </a:r>
           </a:p>
         </p:txBody>
@@ -6712,7 +6712,7 @@
                 </a:solidFill>
                 <a:latin typeface="Arial"/>
               </a:rPr>
-              <a:t>Our console locked on the beacon — the same view the live demo link opens</a:t>
+              <a:t>Our console locked — judges can run this tracker on their own camera</a:t>
             </a:r>
           </a:p>
         </p:txBody>
@@ -7950,7 +7950,7 @@
                 </a:solidFill>
                 <a:latin typeface="Arial"/>
               </a:rPr>
-              <a:t>Standalone Windows/Linux app builds in one click</a:t>
+              <a:t>Standalone Windows/Linux app builds in one click; the browser demo needs no install at all</a:t>
             </a:r>
           </a:p>
           <a:p>
@@ -10104,7 +10104,7 @@
                 </a:solidFill>
                 <a:latin typeface="Arial"/>
               </a:rPr>
-              <a:t>Live demo (replay console):  </a:t>
+              <a:t>Live demo:  </a:t>
             </a:r>
             <a:r>
               <a:rPr sz="1100" u="sng">
@@ -10139,7 +10139,7 @@
                 </a:solidFill>
                 <a:latin typeface="Arial"/>
               </a:rPr>
-              <a:t>full source (5,000+ lines, documented) · 73 automated tests · 6 validated scenarios · Monte-Carlo campaign logs · technical report · user manual · demo video.</a:t>
+              <a:t>full source (5,000+ lines, documented) · 73 automated tests · 6 validated scenarios · Monte-Carlo logs · technical report · user manual · and /live.html, an in-browser tracker that runs on any laptop or phone camera with nothing installed.</a:t>
             </a:r>
           </a:p>
           <a:p>

</xml_diff>